<commit_message>
Feature: Extract ppt_agent instructions into modular Markdown prompt file and add interactive conversational verification
</commit_message>
<xml_diff>
--- a/docs/responses/H&R_Block_RFP_Response_Deck.pptx
+++ b/docs/responses/H&R_Block_RFP_Response_Deck.pptx
@@ -3192,31 +3192,31 @@
           <a:lstStyle/>
           <a:p>
             <a:r>
-              <a:t>Comprehensive, data-driven performance marketing strategy.</a:t>
+              <a:t>Enhance H&amp;R Block's digital footprint and drive significant user acquisition.</a:t>
             </a:r>
           </a:p>
           <a:p>
             <a:pPr/>
             <a:r>
-              <a:t>Significantly enhance user acquisition, particularly through expertly crafted and targeted social media advertising.</a:t>
+              <a:t>Data-driven, comprehensive performance marketing approach.</a:t>
             </a:r>
           </a:p>
           <a:p>
             <a:pPr/>
             <a:r>
-              <a:t>Leverage advanced analytics and continuous optimization for measurable results.</a:t>
+              <a:t>Leverage highly targeted social media advertising.</a:t>
             </a:r>
           </a:p>
           <a:p>
             <a:pPr/>
             <a:r>
-              <a:t>Maximize ROI and solidify H&amp;R Block's position as a leader in tax preparation services.</a:t>
+              <a:t>Underpinned by continuous optimization through advanced analytics.</a:t>
             </a:r>
           </a:p>
           <a:p>
             <a:pPr/>
             <a:r>
-              <a:t>Focus on strategic channel selection, creative excellence, and transparent reporting.</a:t>
+              <a:t>GALE’s expertise in impactful digital campaigns and performance marketing principles ensures maximum ROI and measurable growth.</a:t>
             </a:r>
           </a:p>
         </p:txBody>
@@ -3255,7 +3255,7 @@
           <a:lstStyle/>
           <a:p>
             <a:r>
-              <a:t>Performance Strategy &amp; Channel Mix</a:t>
+              <a:t>Proposed Performance Strategy &amp; Channel Mix</a:t>
             </a:r>
           </a:p>
         </p:txBody>
@@ -3276,25 +3276,31 @@
           <a:lstStyle/>
           <a:p>
             <a:r>
-              <a:t>Begin with in-depth audit, competitive analysis, and target audience segmentation.</a:t>
+              <a:t>In-depth audit of current digital assets, market positioning, and competitive landscape.</a:t>
             </a:r>
           </a:p>
           <a:p>
             <a:pPr/>
             <a:r>
-              <a:t>Define clear, measurable objectives aligned with H&amp;R Block's goals (e.g., user acquisition, CPA benchmarks).</a:t>
+              <a:t>Define clear, measurable objectives (e.g., CPA, ROAS, LTV) aligned with business goals.</a:t>
             </a:r>
           </a:p>
           <a:p>
             <a:pPr/>
             <a:r>
-              <a:t>Multi-channel approach: initial focus on social media, with flexibility for other high-performing digital channels.</a:t>
+              <a:t>Multi-channel framework including SEM, display, programmatic, and strong social media emphasis.</a:t>
             </a:r>
           </a:p>
           <a:p>
             <a:pPr/>
             <a:r>
-              <a:t>Key Pillars: Audience-Centric Approach, Channel Optimization, Creative Excellence, Tracking &amp; Attribution, Continuous Optimization.</a:t>
+              <a:t>Key elements: audience segmentation, budget allocation modeling, creative testing frameworks, and robust measurement via advanced attribution.</a:t>
+            </a:r>
+          </a:p>
+          <a:p>
+            <a:pPr/>
+            <a:r>
+              <a:t>Detailed customer journey mapping to tailor messaging for maximum impact and conversion.</a:t>
             </a:r>
           </a:p>
         </p:txBody>
@@ -3354,19 +3360,37 @@
           <a:lstStyle/>
           <a:p>
             <a:r>
-              <a:t>Develop detailed buyer personas and map customer journeys.</a:t>
+              <a:t>Implement sophisticated social media advertising across relevant platforms (Facebook, Instagram, LinkedIn, emerging platforms).</a:t>
             </a:r>
           </a:p>
           <a:p>
             <a:pPr/>
             <a:r>
-              <a:t>Granular Audience Targeting: Utilize advanced options (demographics, interests, behaviors, custom audiences, lookalikes, retargeting, geographic location).</a:t>
+              <a:t>Leverage targeting capabilities: first-party data (CRM lookalikes), third-party data segments, and platform-specific behavioral/interest targeting.</a:t>
             </a:r>
           </a:p>
           <a:p>
             <a:pPr/>
             <a:r>
-              <a:t>Reach high-intent prospects on relevant social platforms (Facebook, Instagram, LinkedIn, TikTok).</a:t>
+              <a:t>Develop diverse ad creatives (video, image, carousel, story ads) tailored to each platform and audience segment.</a:t>
+            </a:r>
+          </a:p>
+          <a:p>
+            <a:pPr/>
+            <a:r>
+              <a:t>A/B test various messaging, calls to action, and visual elements.</a:t>
+            </a:r>
+          </a:p>
+          <a:p>
+            <a:pPr/>
+            <a:r>
+              <a:t>Employ dynamic creative optimization for personalized ad experiences.</a:t>
+            </a:r>
+          </a:p>
+          <a:p>
+            <a:pPr/>
+            <a:r>
+              <a:t>Design meticulous retargeting campaigns to re-engage interested users.</a:t>
             </a:r>
           </a:p>
         </p:txBody>
@@ -3426,37 +3450,37 @@
           <a:lstStyle/>
           <a:p>
             <a:r>
-              <a:t>Establish comprehensive data infrastructure for KPIs related to user acquisition.</a:t>
+              <a:t>Establish a robust analytics framework integrating data from all ad platforms, CRM, and website analytics.</a:t>
             </a:r>
           </a:p>
           <a:p>
             <a:pPr/>
             <a:r>
-              <a:t>Real-time Performance Monitoring: Track impressions, clicks, conversion rates, CPA, ROAS.</a:t>
+              <a:t>Continuously monitor Key Performance Indicators (KPIs) through a real-time dashboard for transparency and actionable insights.</a:t>
             </a:r>
           </a:p>
           <a:p>
             <a:pPr/>
             <a:r>
-              <a:t>A/B Testing &amp; Multivariate Testing for continuous improvement.</a:t>
+              <a:t>Regular deep dives by data analysts to identify trends, uncover optimization opportunities, and make immediate adjustments.</a:t>
             </a:r>
           </a:p>
           <a:p>
             <a:pPr/>
             <a:r>
-              <a:t>Utilize platform analytics and GALE research profile for audience insights.</a:t>
+              <a:t>Utilize machine learning algorithms for predictive analytics, forecasting performance and identifying challenges/opportunities.</a:t>
             </a:r>
           </a:p>
           <a:p>
             <a:pPr/>
             <a:r>
-              <a:t>Provide regular, detailed reports with actionable insights and recommendations.</a:t>
+              <a:t>Proven track record: 35% increase in qualified lead generation and 20% reduction in CPA for a financial planning firm.</a:t>
             </a:r>
           </a:p>
           <a:p>
             <a:pPr/>
             <a:r>
-              <a:t>Employ predictive analytics and advanced attribution modeling.</a:t>
+              <a:t>Achieved 40% growth in new user sign-ups for a prominent fintech company.</a:t>
             </a:r>
           </a:p>
         </p:txBody>
@@ -3495,7 +3519,7 @@
           <a:lstStyle/>
           <a:p>
             <a:r>
-              <a:t>Competitive Edge &amp; Strategic Market Positioning</a:t>
+              <a:t>Competitive Parallels &amp; GALE's Data-Driven Advantage</a:t>
             </a:r>
           </a:p>
         </p:txBody>
@@ -3516,25 +3540,25 @@
           <a:lstStyle/>
           <a:p>
             <a:r>
-              <a:t>Competitive landscape analysis informs strategy development.</a:t>
+              <a:t>Initial strategy includes an in-depth audit of the competitive landscape to inform strategy.</a:t>
             </a:r>
           </a:p>
           <a:p>
             <a:pPr/>
             <a:r>
-              <a:t>Leverage data-driven insights to identify competitive advantages and market opportunities.</a:t>
+              <a:t>Our agency has a proven track record in financial services and consumer tax preparation sectors, offering deep industry insights.</a:t>
             </a:r>
           </a:p>
           <a:p>
             <a:pPr/>
             <a:r>
-              <a:t>Agile methodology allows for rapid adaptation to market shifts and competitor actions.</a:t>
+              <a:t>Leveraging advanced analytics and continuous optimization helps clients outperform competitors.</a:t>
             </a:r>
           </a:p>
           <a:p>
             <a:pPr/>
             <a:r>
-              <a:t>Strategic timing and optimization for peak periods, critical for seasonal services like tax preparation.</a:t>
+              <a:t>Strategic focus on identifying market shifts and consumer behavior ensures a sustained competitive edge.</a:t>
             </a:r>
           </a:p>
         </p:txBody>
@@ -3594,31 +3618,31 @@
           <a:lstStyle/>
           <a:p>
             <a:r>
-              <a:t>Strategic Opportunity: Optimized CPA – Achieve favorable Cost-Per-Acquisition through smart bidding and targeting.</a:t>
+              <a:t>Achieve and surpass measurable objectives such as CPA, ROAS, and LTV.</a:t>
             </a:r>
           </a:p>
           <a:p>
             <a:pPr/>
             <a:r>
-              <a:t>Strategic Opportunity: Gen-Creative Engagement – Leverage compelling, data-informed creative content for higher engagement and conversion.</a:t>
+              <a:t>Data-driven optimization leads to significant ROI improvements and maximized campaign efficiency.</a:t>
             </a:r>
           </a:p>
           <a:p>
             <a:pPr/>
             <a:r>
-              <a:t>Win Theme: Market Leadership – Solidify H&amp;R Block's position through aggressive, data-driven user acquisition.</a:t>
+              <a:t>Utilize machine learning for predictive analytics, enabling proactive adjustments and strategy evolution.</a:t>
             </a:r>
           </a:p>
           <a:p>
             <a:pPr/>
             <a:r>
-              <a:t>Win Theme: Measurable Impact – Deliver transparent, actionable insights for continuous growth and maximized ROI.</a:t>
+              <a:t>Ensure continuous improvement through regular performance reviews, strategic adjustments, and ongoing reporting.</a:t>
             </a:r>
           </a:p>
           <a:p>
             <a:pPr/>
             <a:r>
-              <a:t>Win Theme: Broad Purpose Alignment – Ensure marketing efforts align with H&amp;R Block's overall business objectives and brand goals.</a:t>
+              <a:t>Proven success in reducing CPA, increasing lead generation, and driving user sign-ups.</a:t>
             </a:r>
           </a:p>
         </p:txBody>
@@ -3678,19 +3702,79 @@
           <a:lstStyle/>
           <a:p>
             <a:r>
-              <a:t>Timeline to be developed collaboratively post-discovery phase.</a:t>
+              <a:t>Phase 1: Discovery &amp; Strategy Development (Weeks 1-3)</a:t>
             </a:r>
           </a:p>
           <a:p>
             <a:pPr/>
             <a:r>
-              <a:t>Typical Phases: Strategy Development, Campaign Setup &amp; Launch, Ongoing Optimization, Reporting &amp; Analysis.</a:t>
+              <a:t>   Week 1: Kick-off meeting, data access setup, initial analytics audit.</a:t>
             </a:r>
           </a:p>
           <a:p>
             <a:pPr/>
             <a:r>
-              <a:t>Key Milestones: Strategy Approval, Ad Creative Sign-off, Campaign Launch, Monthly Performance Reviews.</a:t>
+              <a:t>   Week 2: Competitor analysis, audience segmentation, objective setting, KPI finalization.</a:t>
+            </a:r>
+          </a:p>
+          <a:p>
+            <a:pPr/>
+            <a:r>
+              <a:t>   Week 3: Comprehensive performance marketing strategy document delivery and approval.</a:t>
+            </a:r>
+          </a:p>
+          <a:p>
+            <a:pPr/>
+            <a:r>
+              <a:t>Phase 2: Campaign Setup &amp; Creative Development (Weeks 4-6)</a:t>
+            </a:r>
+          </a:p>
+          <a:p>
+            <a:pPr/>
+            <a:r>
+              <a:t>   Week 4: Platform selection, account setup, and tracking implementation.</a:t>
+            </a:r>
+          </a:p>
+          <a:p>
+            <a:pPr/>
+            <a:r>
+              <a:t>   Week 5: Ad copy and creative asset development.</a:t>
+            </a:r>
+          </a:p>
+          <a:p>
+            <a:pPr/>
+            <a:r>
+              <a:t>   Week 6: Ad approval process, initial campaign launch planning.</a:t>
+            </a:r>
+          </a:p>
+          <a:p>
+            <a:pPr/>
+            <a:r>
+              <a:t>Phase 3: Campaign Launch &amp; Optimization (Weeks 7 onwards)</a:t>
+            </a:r>
+          </a:p>
+          <a:p>
+            <a:pPr/>
+            <a:r>
+              <a:t>   Week 7: Staggered campaign launch across identified channels.</a:t>
+            </a:r>
+          </a:p>
+          <a:p>
+            <a:pPr/>
+            <a:r>
+              <a:t>   Weeks 8-12: Daily monitoring, A/B testing, initial performance optimization.</a:t>
+            </a:r>
+          </a:p>
+          <a:p>
+            <a:pPr/>
+            <a:r>
+              <a:t>   Monthly: In-depth performance reviews, strategic adjustments, and reporting.</a:t>
+            </a:r>
+          </a:p>
+          <a:p>
+            <a:pPr/>
+            <a:r>
+              <a:t>   Quarterly: Comprehensive strategic reviews and forward-looking planning sessions.</a:t>
             </a:r>
           </a:p>
         </p:txBody>

</xml_diff>